<commit_message>
Update buddy pairing presentations
</commit_message>
<xml_diff>
--- a/DIR_DIVING_Full_Feature_Presentation.pptx
+++ b/DIR_DIVING_Full_Feature_Presentation.pptx
@@ -490,7 +490,7 @@
                   <a:srgbClr val="FFFFFF"/>
                 </a:solidFill>
               </a:rPr>
-              <a:t>Buddy Assist Messaging</a:t>
+              <a:t>Pre-Dive Buddy Pairing</a:t>
             </a:r>
             <a:endParaRPr lang="en-US" sz="3300"/>
           </a:p>
@@ -525,29 +525,29 @@
                   <a:srgbClr val="DDEAF0"/>
                 </a:solidFill>
               </a:rPr>
-              <a:t>- Preset buddy messages: OK, RISALI, HO UN PROBLEMA, DOVE SEI?, TORNA INDIETRO, LOW GAS.</a:t>
-            </a:r>
-            <a:endParaRPr lang="en-US" sz="1900"/>
-          </a:p>
-          <a:p>
-            <a:r>
-              <a:rPr lang="en-US" sz="1900">
-                <a:solidFill>
-                  <a:srgbClr val="DDEAF0"/>
-                </a:solidFill>
-              </a:rPr>
-              <a:t>- UI supports pairing state and send controls.</a:t>
-            </a:r>
-            <a:endParaRPr lang="en-US" sz="1900"/>
-          </a:p>
-          <a:p>
-            <a:r>
-              <a:rPr lang="en-US" sz="1900">
-                <a:solidFill>
-                  <a:srgbClr val="DDEAF0"/>
-                </a:solidFill>
-              </a:rPr>
-              <a:t>- CoreBluetooth central-side scaffold is experimental.</a:t>
+              <a:t>- Apple Watch Ultra users identify their DIR DIVING buddy before the dive.</a:t>
+            </a:r>
+            <a:endParaRPr lang="en-US" sz="1900"/>
+          </a:p>
+          <a:p>
+            <a:r>
+              <a:rPr lang="en-US" sz="1900">
+                <a:solidFill>
+                  <a:srgbClr val="DDEAF0"/>
+                </a:solidFill>
+              </a:rPr>
+              <a:t>- PAIRING PRE-DIVE shows PAIRED or NOT PAIRED and stores the buddy identity locally.</a:t>
+            </a:r>
+            <a:endParaRPr lang="en-US" sz="1900"/>
+          </a:p>
+          <a:p>
+            <a:r>
+              <a:rPr lang="en-US" sz="1900">
+                <a:solidFill>
+                  <a:srgbClr val="DDEAF0"/>
+                </a:solidFill>
+              </a:rPr>
+              <a:t>- Pairing is disabled during immersion; the warning remains visible in the Buddy UI.</a:t>
             </a:r>
             <a:endParaRPr lang="en-US" sz="1900"/>
           </a:p>

</xml_diff>

<commit_message>
Document premium UI across branches
</commit_message>
<xml_diff>
--- a/DIR_DIVING_Full_Feature_Presentation.pptx
+++ b/DIR_DIVING_Full_Feature_Presentation.pptx
@@ -188,7 +188,7 @@
                   <a:srgbClr val="DDEAF0"/>
                 </a:solidFill>
               </a:rPr>
-              <a:t>- DIR DIVING is a SwiftUI watchOS dive app for Apple Watch Ultra-class devices.</a:t>
+              <a:t>- DIR DIVING is a SwiftUI watchOS dive app with a premium Apple Watch Ultra-style UI across every screen.</a:t>
             </a:r>
             <a:endParaRPr lang="en-US" sz="1900"/>
           </a:p>
@@ -351,7 +351,7 @@
                   <a:srgbClr val="DDEAF0"/>
                 </a:solidFill>
               </a:rPr>
-              <a:t>- Displays bundled PNG, JPG, JPEG, or HEIC reference screens.</a:t>
+              <a:t>- Premium black image selector displays bundled PNG, JPG, JPEG, or HEIC reference screens.</a:t>
             </a:r>
             <a:endParaRPr lang="en-US" sz="1900"/>
           </a:p>
@@ -536,7 +536,7 @@
                   <a:srgbClr val="DDEAF0"/>
                 </a:solidFill>
               </a:rPr>
-              <a:t>- PAIRING PRE-DIVE shows PAIRED or NOT PAIRED and stores the buddy identity locally.</a:t>
+              <a:t>- PAIRING PRE-DIVE uses the shared premium panel style, shows PAIRED or NOT PAIRED, and stores the buddy identity locally.</a:t>
             </a:r>
             <a:endParaRPr lang="en-US" sz="1900"/>
           </a:p>
@@ -1243,7 +1243,7 @@
                   <a:srgbClr val="DDEAF0"/>
                 </a:solidFill>
               </a:rPr>
-              <a:t>- Built for glanceable underwater readability.</a:t>
+              <a:t>- Built around the shared premium black dive-computer visual system.</a:t>
             </a:r>
             <a:endParaRPr lang="en-US" sz="1900"/>
           </a:p>
@@ -1743,7 +1743,7 @@
                   <a:srgbClr val="DDEAF0"/>
                 </a:solidFill>
               </a:rPr>
-              <a:t>- Full compass screen with heading and cardinal direction.</a:t>
+              <a:t>- Premium black compass screen with large heading, bearing panel, and technical controls.</a:t>
             </a:r>
             <a:endParaRPr lang="en-US" sz="1900"/>
           </a:p>
@@ -2091,7 +2091,7 @@
                   <a:srgbClr val="DDEAF0"/>
                 </a:solidFill>
               </a:rPr>
-              <a:t>- Stores the latest 40 dives locally.</a:t>
+              <a:t>- Premium black log screen stores the latest 40 dives locally.</a:t>
             </a:r>
             <a:endParaRPr lang="en-US" sz="1900"/>
           </a:p>

</xml_diff>

<commit_message>
Document premium live mockup alignment
</commit_message>
<xml_diff>
--- a/DIR_DIVING_Full_Feature_Presentation.pptx
+++ b/DIR_DIVING_Full_Feature_Presentation.pptx
@@ -1,5 +1,27 @@
 
-<file path=ppt/presentation.xml><?xml version="1.0" encoding="utf-8"?>
+<file path=docProps\app.xml><?xml version="1.0" encoding="utf-8"?>
+<Properties xmlns="http://schemas.openxmlformats.org/officeDocument/2006/extended-properties" xmlns:vt="http://schemas.openxmlformats.org/officeDocument/2006/docPropsVTypes">
+  <Application>DIR DIVING</Application>
+  <PresentationFormat>On-screen Show (16:9)</PresentationFormat>
+  <Slides>14</Slides>
+</Properties>
+</file>
+
+<file path=docProps\core.xml><?xml version="1.0" encoding="utf-8"?>
+<cp:coreProperties xmlns:cp="http://schemas.openxmlformats.org/package/2006/metadata/core-properties" xmlns:dc="http://purl.org/dc/elements/1.1/" xmlns:dcterms="http://purl.org/dc/terms/" xmlns:dcmitype="http://purl.org/dc/dcmitype/" xmlns:xsi="http://www.w3.org/2001/XMLSchema-instance">
+  <dc:title>DIR DIVING Full Feature Presentation</dc:title>
+  <dc:creator>DIR DIVING</dc:creator>
+  <cp:lastModifiedBy>DIR DIVING</cp:lastModifiedBy>
+  <dcterms:created xsi:type="dcterms:W3CDTF">2026-05-10T11:22:59Z</dcterms:created>
+  <dcterms:modified xsi:type="dcterms:W3CDTF">2026-05-10T11:22:59Z</dcterms:modified>
+</cp:coreProperties>
+</file>
+
+<file path=ppt\presProps.xml><?xml version="1.0" encoding="utf-8"?>
+<p:presentationPr xmlns:p="http://schemas.openxmlformats.org/presentationml/2006/main"/>
+</file>
+
+<file path=ppt\presentation.xml><?xml version="1.0" encoding="utf-8"?>
 <p:presentation xmlns:a="http://schemas.openxmlformats.org/drawingml/2006/main" xmlns:r="http://schemas.openxmlformats.org/officeDocument/2006/relationships" xmlns:p="http://schemas.openxmlformats.org/presentationml/2006/main">
   <p:sldMasterIdLst>
     <p:sldMasterId id="2147483648" r:id="rId15"/>
@@ -26,7 +48,7 @@
 </p:presentation>
 </file>
 
-<file path=ppt/slideLayouts/slideLayout1.xml><?xml version="1.0" encoding="utf-8"?>
+<file path=ppt\slideLayouts\slideLayout1.xml><?xml version="1.0" encoding="utf-8"?>
 <p:sldLayout xmlns:a="http://schemas.openxmlformats.org/drawingml/2006/main" xmlns:r="http://schemas.openxmlformats.org/officeDocument/2006/relationships" xmlns:p="http://schemas.openxmlformats.org/presentationml/2006/main" type="blank" preserve="1">
   <p:cSld name="Blank">
     <p:spTree>
@@ -51,7 +73,7 @@
 </p:sldLayout>
 </file>
 
-<file path=ppt/slideMasters/slideMaster1.xml><?xml version="1.0" encoding="utf-8"?>
+<file path=ppt\slideMasters\slideMaster1.xml><?xml version="1.0" encoding="utf-8"?>
 <p:sldMaster xmlns:a="http://schemas.openxmlformats.org/drawingml/2006/main" xmlns:r="http://schemas.openxmlformats.org/officeDocument/2006/relationships" xmlns:p="http://schemas.openxmlformats.org/presentationml/2006/main">
   <p:cSld>
     <p:spTree>
@@ -77,7 +99,7 @@
 </p:sldMaster>
 </file>
 
-<file path=ppt/slides/slide1.xml><?xml version="1.0" encoding="utf-8"?>
+<file path=ppt\slides\slide1.xml><?xml version="1.0" encoding="utf-8"?>
 <p:sld xmlns:a="http://schemas.openxmlformats.org/drawingml/2006/main" xmlns:r="http://schemas.openxmlformats.org/officeDocument/2006/relationships" xmlns:p="http://schemas.openxmlformats.org/presentationml/2006/main">
   <p:cSld>
     <p:bg>
@@ -188,7 +210,7 @@
                   <a:srgbClr val="DDEAF0"/>
                 </a:solidFill>
               </a:rPr>
-              <a:t>- DIR DIVING is a SwiftUI watchOS dive app with a premium Apple Watch Ultra-style UI across every screen.</a:t>
+              <a:t>- DIR DIVING is a SwiftUI watchOS dive app with a premium Apple Watch Ultra-style UI, now anchored to the supplied live-dive mockup across every screen.</a:t>
             </a:r>
             <a:endParaRPr lang="en-US" sz="1900"/>
           </a:p>
@@ -240,7 +262,7 @@
 </p:sld>
 </file>
 
-<file path=ppt/slides/slide10.xml><?xml version="1.0" encoding="utf-8"?>
+<file path=ppt\slides\slide10.xml><?xml version="1.0" encoding="utf-8"?>
 <p:sld xmlns:a="http://schemas.openxmlformats.org/drawingml/2006/main" xmlns:r="http://schemas.openxmlformats.org/officeDocument/2006/relationships" xmlns:p="http://schemas.openxmlformats.org/presentationml/2006/main">
   <p:cSld>
     <p:bg>
@@ -414,7 +436,7 @@
 </p:sld>
 </file>
 
-<file path=ppt/slides/slide11.xml><?xml version="1.0" encoding="utf-8"?>
+<file path=ppt\slides\slide11.xml><?xml version="1.0" encoding="utf-8"?>
 <p:sld xmlns:a="http://schemas.openxmlformats.org/drawingml/2006/main" xmlns:r="http://schemas.openxmlformats.org/officeDocument/2006/relationships" xmlns:p="http://schemas.openxmlformats.org/presentationml/2006/main">
   <p:cSld>
     <p:bg>
@@ -588,7 +610,7 @@
 </p:sld>
 </file>
 
-<file path=ppt/slides/slide12.xml><?xml version="1.0" encoding="utf-8"?>
+<file path=ppt\slides\slide12.xml><?xml version="1.0" encoding="utf-8"?>
 <p:sld xmlns:a="http://schemas.openxmlformats.org/drawingml/2006/main" xmlns:r="http://schemas.openxmlformats.org/officeDocument/2006/relationships" xmlns:p="http://schemas.openxmlformats.org/presentationml/2006/main">
   <p:cSld>
     <p:bg>
@@ -762,7 +784,7 @@
 </p:sld>
 </file>
 
-<file path=ppt/slides/slide13.xml><?xml version="1.0" encoding="utf-8"?>
+<file path=ppt\slides\slide13.xml><?xml version="1.0" encoding="utf-8"?>
 <p:sld xmlns:a="http://schemas.openxmlformats.org/drawingml/2006/main" xmlns:r="http://schemas.openxmlformats.org/officeDocument/2006/relationships" xmlns:p="http://schemas.openxmlformats.org/presentationml/2006/main">
   <p:cSld>
     <p:bg>
@@ -936,7 +958,7 @@
 </p:sld>
 </file>
 
-<file path=ppt/slides/slide14.xml><?xml version="1.0" encoding="utf-8"?>
+<file path=ppt\slides\slide14.xml><?xml version="1.0" encoding="utf-8"?>
 <p:sld xmlns:a="http://schemas.openxmlformats.org/drawingml/2006/main" xmlns:r="http://schemas.openxmlformats.org/officeDocument/2006/relationships" xmlns:p="http://schemas.openxmlformats.org/presentationml/2006/main">
   <p:cSld>
     <p:bg>
@@ -1110,7 +1132,7 @@
 </p:sld>
 </file>
 
-<file path=ppt/slides/slide2.xml><?xml version="1.0" encoding="utf-8"?>
+<file path=ppt\slides\slide2.xml><?xml version="1.0" encoding="utf-8"?>
 <p:sld xmlns:a="http://schemas.openxmlformats.org/drawingml/2006/main" xmlns:r="http://schemas.openxmlformats.org/officeDocument/2006/relationships" xmlns:p="http://schemas.openxmlformats.org/presentationml/2006/main">
   <p:cSld>
     <p:bg>
@@ -1221,29 +1243,29 @@
                   <a:srgbClr val="DDEAF0"/>
                 </a:solidFill>
               </a:rPr>
-              <a:t>- Shows current, maximum, and average depth.</a:t>
-            </a:r>
-            <a:endParaRPr lang="en-US" sz="1900"/>
-          </a:p>
-          <a:p>
-            <a:r>
-              <a:rPr lang="en-US" sz="1900">
-                <a:solidFill>
-                  <a:srgbClr val="DDEAF0"/>
-                </a:solidFill>
-              </a:rPr>
-              <a:t>- Displays water temperature, RunTime, TTV, and warning state.</a:t>
-            </a:r>
-            <a:endParaRPr lang="en-US" sz="1900"/>
-          </a:p>
-          <a:p>
-            <a:r>
-              <a:rPr lang="en-US" sz="1900">
-                <a:solidFill>
-                  <a:srgbClr val="DDEAF0"/>
-                </a:solidFill>
-              </a:rPr>
-              <a:t>- Built around the shared premium black dive-computer visual system.</a:t>
+              <a:t>- Shows current, maximum, and average depth with the large live depth value matching the Apple Watch Ultra reference layout.</a:t>
+            </a:r>
+            <a:endParaRPr lang="en-US" sz="1900"/>
+          </a:p>
+          <a:p>
+            <a:r>
+              <a:rPr lang="en-US" sz="1900">
+                <a:solidFill>
+                  <a:srgbClr val="DDEAF0"/>
+                </a:solidFill>
+              </a:rPr>
+              <a:t>- Displays water temperature, RunTime, TTV, stopwatch, and ascent state in the same functional color language as the mockup.</a:t>
+            </a:r>
+            <a:endParaRPr lang="en-US" sz="1900"/>
+          </a:p>
+          <a:p>
+            <a:r>
+              <a:rPr lang="en-US" sz="1900">
+                <a:solidFill>
+                  <a:srgbClr val="DDEAF0"/>
+                </a:solidFill>
+              </a:rPr>
+              <a:t>- Built around the supplied premium mockup: black canvas, octopus logo, separated ascent gauge, blue labels, and non-overlapping metric regions.</a:t>
             </a:r>
             <a:endParaRPr lang="en-US" sz="1900"/>
           </a:p>
@@ -1284,7 +1306,7 @@
 </p:sld>
 </file>
 
-<file path=ppt/slides/slide3.xml><?xml version="1.0" encoding="utf-8"?>
+<file path=ppt\slides\slide3.xml><?xml version="1.0" encoding="utf-8"?>
 <p:sld xmlns:a="http://schemas.openxmlformats.org/drawingml/2006/main" xmlns:r="http://schemas.openxmlformats.org/officeDocument/2006/relationships" xmlns:p="http://schemas.openxmlformats.org/presentationml/2006/main">
   <p:cSld>
     <p:bg>
@@ -1458,7 +1480,7 @@
 </p:sld>
 </file>
 
-<file path=ppt/slides/slide4.xml><?xml version="1.0" encoding="utf-8"?>
+<file path=ppt\slides\slide4.xml><?xml version="1.0" encoding="utf-8"?>
 <p:sld xmlns:a="http://schemas.openxmlformats.org/drawingml/2006/main" xmlns:r="http://schemas.openxmlformats.org/officeDocument/2006/relationships" xmlns:p="http://schemas.openxmlformats.org/presentationml/2006/main">
   <p:cSld>
     <p:bg>
@@ -1632,7 +1654,7 @@
 </p:sld>
 </file>
 
-<file path=ppt/slides/slide5.xml><?xml version="1.0" encoding="utf-8"?>
+<file path=ppt\slides\slide5.xml><?xml version="1.0" encoding="utf-8"?>
 <p:sld xmlns:a="http://schemas.openxmlformats.org/drawingml/2006/main" xmlns:r="http://schemas.openxmlformats.org/officeDocument/2006/relationships" xmlns:p="http://schemas.openxmlformats.org/presentationml/2006/main">
   <p:cSld>
     <p:bg>
@@ -1806,7 +1828,7 @@
 </p:sld>
 </file>
 
-<file path=ppt/slides/slide6.xml><?xml version="1.0" encoding="utf-8"?>
+<file path=ppt\slides\slide6.xml><?xml version="1.0" encoding="utf-8"?>
 <p:sld xmlns:a="http://schemas.openxmlformats.org/drawingml/2006/main" xmlns:r="http://schemas.openxmlformats.org/officeDocument/2006/relationships" xmlns:p="http://schemas.openxmlformats.org/presentationml/2006/main">
   <p:cSld>
     <p:bg>
@@ -1980,7 +2002,7 @@
 </p:sld>
 </file>
 
-<file path=ppt/slides/slide7.xml><?xml version="1.0" encoding="utf-8"?>
+<file path=ppt\slides\slide7.xml><?xml version="1.0" encoding="utf-8"?>
 <p:sld xmlns:a="http://schemas.openxmlformats.org/drawingml/2006/main" xmlns:r="http://schemas.openxmlformats.org/officeDocument/2006/relationships" xmlns:p="http://schemas.openxmlformats.org/presentationml/2006/main">
   <p:cSld>
     <p:bg>
@@ -2154,7 +2176,7 @@
 </p:sld>
 </file>
 
-<file path=ppt/slides/slide8.xml><?xml version="1.0" encoding="utf-8"?>
+<file path=ppt\slides\slide8.xml><?xml version="1.0" encoding="utf-8"?>
 <p:sld xmlns:a="http://schemas.openxmlformats.org/drawingml/2006/main" xmlns:r="http://schemas.openxmlformats.org/officeDocument/2006/relationships" xmlns:p="http://schemas.openxmlformats.org/presentationml/2006/main">
   <p:cSld>
     <p:bg>
@@ -2328,7 +2350,7 @@
 </p:sld>
 </file>
 
-<file path=ppt/slides/slide9.xml><?xml version="1.0" encoding="utf-8"?>
+<file path=ppt\slides\slide9.xml><?xml version="1.0" encoding="utf-8"?>
 <p:sld xmlns:a="http://schemas.openxmlformats.org/drawingml/2006/main" xmlns:r="http://schemas.openxmlformats.org/officeDocument/2006/relationships" xmlns:p="http://schemas.openxmlformats.org/presentationml/2006/main">
   <p:cSld>
     <p:bg>
@@ -2502,7 +2524,7 @@
 </p:sld>
 </file>
 
-<file path=ppt/theme/theme1.xml><?xml version="1.0" encoding="utf-8"?>
+<file path=ppt\theme\theme1.xml><?xml version="1.0" encoding="utf-8"?>
 <a:theme xmlns:a="http://schemas.openxmlformats.org/drawingml/2006/main" name="DIR DIVING">
   <a:themeElements>
     <a:clrScheme name="DIR DIVING">
@@ -2577,4 +2599,8 @@
     </a:fmtScheme>
   </a:themeElements>
 </a:theme>
+</file>
+
+<file path=ppt\viewProps.xml><?xml version="1.0" encoding="utf-8"?>
+<p:viewPr xmlns:p="http://schemas.openxmlformats.org/presentationml/2006/main"/>
 </file>
</xml_diff>